<commit_message>
docs: presentación gerencial en PDF y títulos alineados a la izquierda
El PDF sale de convertir el .pptx con LibreOffice: 13 láminas en 16:9.
Esa conversión mostró que los títulos quedaban centrados mientras el
cuerpo va a la izquierda; ahora todos los layouts los alinean a la
izquierda.

Co-Authored-By: Claude Opus 5.5 <noreply@anthropic.com>
Claude-Session: https://claude.ai/code/session_01VY8B7vMiH1VMUZZi5pu2Gq
</commit_message>
<xml_diff>
--- a/docs/relacionamiento/Relacionamiento-Presentacion-Gerencial.pptx
+++ b/docs/relacionamiento/Relacionamiento-Presentacion-Gerencial.pptx
@@ -119,19 +119,19 @@
   <p:extLst>
     <p:ext uri="{521415D9-36F7-43E2-AB2F-B90AF26B5E84}">
       <p14:sectionLst xmlns:p14="http://schemas.microsoft.com/office/powerpoint/2010/main">
-        <p14:section name="Apertura" id="{73fd64ce-7eab-062c-ee8e-576a70fe6b37}">
+        <p14:section name="Apertura" id="{b1bb0dfa-9f4d-7cbe-550f-241da2fee215}">
           <p14:sldIdLst>
             <p14:sldId id="256"/>
             <p14:sldId id="257"/>
           </p14:sldIdLst>
         </p14:section>
-        <p14:section name="El enfoque" id="{34d0de4c-bc42-47de-134b-3b880a93122f}">
+        <p14:section name="El enfoque" id="{7ace3e38-00b2-5646-bd93-c8f8e94fb4dd}">
           <p14:sldIdLst>
             <p14:sldId id="258"/>
             <p14:sldId id="259"/>
           </p14:sldIdLst>
         </p14:section>
-        <p14:section name="Relacionamiento" id="{ad08160b-3733-6ff4-dba7-657bd27a9f0d}">
+        <p14:section name="Relacionamiento" id="{89343a7f-d986-8bb9-d8d2-e8d55e97ede4}">
           <p14:sldIdLst>
             <p14:sldId id="260"/>
             <p14:sldId id="261"/>
@@ -140,13 +140,13 @@
             <p14:sldId id="264"/>
           </p14:sldIdLst>
         </p14:section>
-        <p14:section name="Cómo comunicamos" id="{e6db3cd6-11a8-aae0-5a86-313f869da7e0}">
+        <p14:section name="Cómo comunicamos" id="{345f767d-30e6-a43a-b6cd-5cfe1df34955}">
           <p14:sldIdLst>
             <p14:sldId id="265"/>
             <p14:sldId id="266"/>
           </p14:sldIdLst>
         </p14:section>
-        <p14:section name="Próximos pasos" id="{3ac2c263-5a05-6a02-78dd-5d0b7c669439}">
+        <p14:section name="Próximos pasos" id="{3f90cc97-f63a-9965-e942-1fcd965b51e3}">
           <p14:sldIdLst>
             <p14:sldId id="267"/>
             <p14:sldId id="268"/>
@@ -2018,7 +2018,7 @@
         <p:txBody>
           <a:bodyPr wrap="square" rtlCol="0"/>
           <a:lstStyle>
-            <a:lvl1pPr indent="0" marL="0">
+            <a:lvl1pPr algn="l" indent="0" marL="0">
               <a:buNone/>
               <a:defRPr lang="en-US" sz="4400" b="1" dirty="0">
                 <a:solidFill>
@@ -2028,7 +2028,7 @@
             </a:lvl1pPr>
           </a:lstStyle>
           <a:p>
-            <a:pPr indent="0" marL="0">
+            <a:pPr algn="l" indent="0" marL="0">
               <a:buNone/>
             </a:pPr>
             <a:endParaRPr lang="en-US" sz="4400" dirty="0"/>
@@ -2128,7 +2128,7 @@
         <p:txBody>
           <a:bodyPr wrap="square" rtlCol="0"/>
           <a:lstStyle>
-            <a:lvl1pPr indent="0" marL="0">
+            <a:lvl1pPr algn="l" indent="0" marL="0">
               <a:buNone/>
               <a:defRPr lang="en-US" sz="4000" b="1" dirty="0">
                 <a:solidFill>
@@ -2138,7 +2138,7 @@
             </a:lvl1pPr>
           </a:lstStyle>
           <a:p>
-            <a:pPr indent="0" marL="0">
+            <a:pPr algn="l" indent="0" marL="0">
               <a:buNone/>
             </a:pPr>
             <a:endParaRPr lang="en-US" sz="4000" dirty="0"/>
@@ -2238,7 +2238,7 @@
         <p:txBody>
           <a:bodyPr wrap="square" rtlCol="0"/>
           <a:lstStyle>
-            <a:lvl1pPr indent="0" marL="0">
+            <a:lvl1pPr algn="l" indent="0" marL="0">
               <a:buNone/>
               <a:defRPr lang="en-US" sz="3200" b="1" dirty="0">
                 <a:solidFill>
@@ -2248,7 +2248,7 @@
             </a:lvl1pPr>
           </a:lstStyle>
           <a:p>
-            <a:pPr indent="0" marL="0">
+            <a:pPr algn="l" indent="0" marL="0">
               <a:buNone/>
             </a:pPr>
             <a:endParaRPr lang="en-US" sz="3200" dirty="0"/>
@@ -2390,7 +2390,7 @@
         <p:txBody>
           <a:bodyPr wrap="square" rtlCol="0"/>
           <a:lstStyle>
-            <a:lvl1pPr indent="0" marL="0">
+            <a:lvl1pPr algn="l" indent="0" marL="0">
               <a:buNone/>
               <a:defRPr lang="en-US" sz="3600" b="1" dirty="0">
                 <a:solidFill>
@@ -2400,7 +2400,7 @@
             </a:lvl1pPr>
           </a:lstStyle>
           <a:p>
-            <a:pPr indent="0" marL="0">
+            <a:pPr algn="l" indent="0" marL="0">
               <a:buNone/>
             </a:pPr>
             <a:endParaRPr lang="en-US" sz="3600" dirty="0"/>
@@ -2781,7 +2781,7 @@
           <a:bodyPr wrap="square" lIns="0" tIns="0" rIns="0" bIns="0" rtlCol="0" anchor="b"/>
           <a:lstStyle/>
           <a:p>
-            <a:pPr indent="0" marL="0">
+            <a:pPr algn="l" indent="0" marL="0">
               <a:buNone/>
             </a:pPr>
             <a:r>
@@ -2967,7 +2967,7 @@
           <a:bodyPr wrap="square" lIns="0" tIns="0" rIns="0" bIns="0" rtlCol="0" anchor="ctr"/>
           <a:lstStyle/>
           <a:p>
-            <a:pPr indent="0" marL="0">
+            <a:pPr algn="l" indent="0" marL="0">
               <a:buNone/>
             </a:pPr>
             <a:r>
@@ -5025,7 +5025,7 @@
           <a:bodyPr wrap="square" lIns="0" tIns="0" rIns="0" bIns="0" rtlCol="0" anchor="ctr"/>
           <a:lstStyle/>
           <a:p>
-            <a:pPr indent="0" marL="0">
+            <a:pPr algn="l" indent="0" marL="0">
               <a:buNone/>
             </a:pPr>
             <a:r>
@@ -5889,7 +5889,7 @@
           <a:bodyPr wrap="square" lIns="0" tIns="0" rIns="0" bIns="0" rtlCol="0" anchor="ctr"/>
           <a:lstStyle/>
           <a:p>
-            <a:pPr indent="0" marL="0">
+            <a:pPr algn="l" indent="0" marL="0">
               <a:buNone/>
             </a:pPr>
             <a:r>
@@ -6626,7 +6626,7 @@
           <a:bodyPr wrap="square" lIns="0" tIns="0" rIns="0" bIns="0" rtlCol="0" anchor="ctr"/>
           <a:lstStyle/>
           <a:p>
-            <a:pPr indent="0" marL="0">
+            <a:pPr algn="l" indent="0" marL="0">
               <a:buNone/>
             </a:pPr>
             <a:r>
@@ -7025,7 +7025,7 @@
           <a:bodyPr wrap="square" lIns="0" tIns="0" rIns="0" bIns="0" rtlCol="0" anchor="ctr"/>
           <a:lstStyle/>
           <a:p>
-            <a:pPr indent="0" marL="0">
+            <a:pPr algn="l" indent="0" marL="0">
               <a:buNone/>
             </a:pPr>
             <a:r>
@@ -7630,7 +7630,7 @@
           <a:bodyPr wrap="square" lIns="0" tIns="0" rIns="0" bIns="0" rtlCol="0" anchor="ctr"/>
           <a:lstStyle/>
           <a:p>
-            <a:pPr indent="0" marL="0">
+            <a:pPr algn="l" indent="0" marL="0">
               <a:buNone/>
             </a:pPr>
             <a:r>
@@ -8210,7 +8210,7 @@
           <a:bodyPr wrap="square" lIns="0" tIns="0" rIns="0" bIns="0" rtlCol="0" anchor="ctr"/>
           <a:lstStyle/>
           <a:p>
-            <a:pPr indent="0" marL="0">
+            <a:pPr algn="l" indent="0" marL="0">
               <a:buNone/>
             </a:pPr>
             <a:r>
@@ -8997,7 +8997,7 @@
           <a:bodyPr wrap="square" lIns="0" tIns="0" rIns="0" bIns="0" rtlCol="0" anchor="ctr"/>
           <a:lstStyle/>
           <a:p>
-            <a:pPr indent="0" marL="0">
+            <a:pPr algn="l" indent="0" marL="0">
               <a:buNone/>
             </a:pPr>
             <a:r>
@@ -9147,7 +9147,7 @@
           <a:bodyPr wrap="square" lIns="0" tIns="0" rIns="0" bIns="0" rtlCol="0" anchor="ctr"/>
           <a:lstStyle/>
           <a:p>
-            <a:pPr indent="0" marL="0">
+            <a:pPr algn="l" indent="0" marL="0">
               <a:buNone/>
             </a:pPr>
             <a:r>
@@ -10143,7 +10143,7 @@
           <a:bodyPr wrap="square" lIns="0" tIns="0" rIns="0" bIns="0" rtlCol="0" anchor="ctr"/>
           <a:lstStyle/>
           <a:p>
-            <a:pPr indent="0" marL="0">
+            <a:pPr algn="l" indent="0" marL="0">
               <a:buNone/>
             </a:pPr>
             <a:r>
@@ -10886,7 +10886,7 @@
           <a:bodyPr wrap="square" lIns="0" tIns="0" rIns="0" bIns="0" rtlCol="0" anchor="ctr"/>
           <a:lstStyle/>
           <a:p>
-            <a:pPr indent="0" marL="0">
+            <a:pPr algn="l" indent="0" marL="0">
               <a:buNone/>
             </a:pPr>
             <a:r>
@@ -11221,7 +11221,7 @@
           <a:bodyPr wrap="square" lIns="0" tIns="0" rIns="0" bIns="0" rtlCol="0" anchor="ctr"/>
           <a:lstStyle/>
           <a:p>
-            <a:pPr indent="0" marL="0">
+            <a:pPr algn="l" indent="0" marL="0">
               <a:buNone/>
             </a:pPr>
             <a:r>

</xml_diff>